<commit_message>
LAB 3 TERMINADO DEFINITIVO
</commit_message>
<xml_diff>
--- a/LabBook_3.pptx
+++ b/LabBook_3.pptx
@@ -5,10 +5,10 @@
     <p:sldMasterId id="2147483648" r:id="rId1"/>
   </p:sldMasterIdLst>
   <p:notesMasterIdLst>
-    <p:notesMasterId r:id="rId12"/>
+    <p:notesMasterId r:id="rId15"/>
   </p:notesMasterIdLst>
   <p:handoutMasterIdLst>
-    <p:handoutMasterId r:id="rId13"/>
+    <p:handoutMasterId r:id="rId16"/>
   </p:handoutMasterIdLst>
   <p:sldIdLst>
     <p:sldId id="256" r:id="rId2"/>
@@ -20,7 +20,10 @@
     <p:sldId id="296" r:id="rId8"/>
     <p:sldId id="299" r:id="rId9"/>
     <p:sldId id="293" r:id="rId10"/>
-    <p:sldId id="288" r:id="rId11"/>
+    <p:sldId id="300" r:id="rId11"/>
+    <p:sldId id="301" r:id="rId12"/>
+    <p:sldId id="302" r:id="rId13"/>
+    <p:sldId id="288" r:id="rId14"/>
   </p:sldIdLst>
   <p:sldSz cx="12192000" cy="6858000"/>
   <p:notesSz cx="12192000" cy="6858000"/>
@@ -235,7 +238,7 @@
           <a:p>
             <a:fld id="{8438F8DC-35B0-48E6-A86E-42F1F08DD00F}" type="datetimeFigureOut">
               <a:rPr lang="es-ES" smtClean="0"/>
-              <a:t>09/03/2026</a:t>
+              <a:t>22/03/2026</a:t>
             </a:fld>
             <a:endParaRPr lang="es-ES"/>
           </a:p>
@@ -412,7 +415,7 @@
           <a:p>
             <a:fld id="{FACBDC12-F39B-4B97-8F4D-6734F9D366FF}" type="datetimeFigureOut">
               <a:rPr lang="es-ES" smtClean="0"/>
-              <a:t>09/03/2026</a:t>
+              <a:t>22/03/2026</a:t>
             </a:fld>
             <a:endParaRPr lang="es-ES"/>
           </a:p>
@@ -2723,6 +2726,966 @@
   <p:cSld>
     <p:spTree>
       <p:nvGrpSpPr>
+        <p:cNvPr id="1" name="">
+          <a:extLst>
+            <a:ext uri="{FF2B5EF4-FFF2-40B4-BE49-F238E27FC236}">
+              <a16:creationId xmlns:a16="http://schemas.microsoft.com/office/drawing/2014/main" id="{5B402102-EFB7-9B5E-498F-8C5752A06A88}"/>
+            </a:ext>
+          </a:extLst>
+        </p:cNvPr>
+        <p:cNvGrpSpPr/>
+        <p:nvPr/>
+      </p:nvGrpSpPr>
+      <p:grpSpPr>
+        <a:xfrm>
+          <a:off x="0" y="0"/>
+          <a:ext cx="0" cy="0"/>
+          <a:chOff x="0" y="0"/>
+          <a:chExt cx="0" cy="0"/>
+        </a:xfrm>
+      </p:grpSpPr>
+      <p:sp>
+        <p:nvSpPr>
+          <p:cNvPr id="2" name="Título 1">
+            <a:extLst>
+              <a:ext uri="{FF2B5EF4-FFF2-40B4-BE49-F238E27FC236}">
+                <a16:creationId xmlns:a16="http://schemas.microsoft.com/office/drawing/2014/main" id="{0BACA8AF-CEA7-1C50-0EAE-9E074568B961}"/>
+              </a:ext>
+            </a:extLst>
+          </p:cNvPr>
+          <p:cNvSpPr>
+            <a:spLocks noGrp="1"/>
+          </p:cNvSpPr>
+          <p:nvPr>
+            <p:ph type="title"/>
+          </p:nvPr>
+        </p:nvSpPr>
+        <p:spPr>
+          <a:xfrm>
+            <a:off x="600075" y="316301"/>
+            <a:ext cx="10991850" cy="307777"/>
+          </a:xfrm>
+        </p:spPr>
+        <p:txBody>
+          <a:bodyPr/>
+          <a:lstStyle/>
+          <a:p>
+            <a:r>
+              <a:rPr lang="es-ES" dirty="0"/>
+              <a:t>RESULTADO ASSESSMENT 4</a:t>
+            </a:r>
+          </a:p>
+        </p:txBody>
+      </p:sp>
+      <p:sp>
+        <p:nvSpPr>
+          <p:cNvPr id="4" name="Marcador de pie de página 3">
+            <a:extLst>
+              <a:ext uri="{FF2B5EF4-FFF2-40B4-BE49-F238E27FC236}">
+                <a16:creationId xmlns:a16="http://schemas.microsoft.com/office/drawing/2014/main" id="{73C069A9-3FDF-3C09-8925-033C88CDD698}"/>
+              </a:ext>
+            </a:extLst>
+          </p:cNvPr>
+          <p:cNvSpPr>
+            <a:spLocks noGrp="1"/>
+          </p:cNvSpPr>
+          <p:nvPr>
+            <p:ph type="ftr" sz="quarter" idx="5"/>
+          </p:nvPr>
+        </p:nvSpPr>
+        <p:spPr/>
+        <p:txBody>
+          <a:bodyPr/>
+          <a:lstStyle/>
+          <a:p>
+            <a:pPr marL="12700">
+              <a:spcBef>
+                <a:spcPts val="15"/>
+              </a:spcBef>
+            </a:pPr>
+            <a:r>
+              <a:rPr lang="es-ES" spc="-5"/>
+              <a:t>LAB 3. INTERFEROMETERS I</a:t>
+            </a:r>
+            <a:endParaRPr lang="es-ES" spc="-5" dirty="0"/>
+          </a:p>
+        </p:txBody>
+      </p:sp>
+      <p:sp>
+        <p:nvSpPr>
+          <p:cNvPr id="5" name="Marcador de número de diapositiva 4">
+            <a:extLst>
+              <a:ext uri="{FF2B5EF4-FFF2-40B4-BE49-F238E27FC236}">
+                <a16:creationId xmlns:a16="http://schemas.microsoft.com/office/drawing/2014/main" id="{76178692-9055-D866-F184-BC07CF583E41}"/>
+              </a:ext>
+            </a:extLst>
+          </p:cNvPr>
+          <p:cNvSpPr>
+            <a:spLocks noGrp="1"/>
+          </p:cNvSpPr>
+          <p:nvPr>
+            <p:ph type="sldNum" sz="quarter" idx="7"/>
+          </p:nvPr>
+        </p:nvSpPr>
+        <p:spPr/>
+        <p:txBody>
+          <a:bodyPr/>
+          <a:lstStyle/>
+          <a:p>
+            <a:fld id="{B6F15528-21DE-4FAA-801E-634DDDAF4B2B}" type="slidenum">
+              <a:rPr lang="es-ES" smtClean="0"/>
+              <a:t>10</a:t>
+            </a:fld>
+            <a:endParaRPr lang="es-ES"/>
+          </a:p>
+        </p:txBody>
+      </p:sp>
+      <p:pic>
+        <p:nvPicPr>
+          <p:cNvPr id="6" name="Imagen 5">
+            <a:extLst>
+              <a:ext uri="{FF2B5EF4-FFF2-40B4-BE49-F238E27FC236}">
+                <a16:creationId xmlns:a16="http://schemas.microsoft.com/office/drawing/2014/main" id="{7688E497-4CC4-0DD9-0FD6-42BA7FEE4F4F}"/>
+              </a:ext>
+            </a:extLst>
+          </p:cNvPr>
+          <p:cNvPicPr>
+            <a:picLocks noChangeAspect="1"/>
+          </p:cNvPicPr>
+          <p:nvPr/>
+        </p:nvPicPr>
+        <p:blipFill>
+          <a:blip r:embed="rId2"/>
+          <a:stretch>
+            <a:fillRect/>
+          </a:stretch>
+        </p:blipFill>
+        <p:spPr>
+          <a:xfrm>
+            <a:off x="274857" y="1447800"/>
+            <a:ext cx="6155886" cy="3762375"/>
+          </a:xfrm>
+          <a:prstGeom prst="rect">
+            <a:avLst/>
+          </a:prstGeom>
+        </p:spPr>
+      </p:pic>
+      <p:sp>
+        <p:nvSpPr>
+          <p:cNvPr id="10" name="Rectangle 1">
+            <a:extLst>
+              <a:ext uri="{FF2B5EF4-FFF2-40B4-BE49-F238E27FC236}">
+                <a16:creationId xmlns:a16="http://schemas.microsoft.com/office/drawing/2014/main" id="{09BDA639-D7FF-D119-3475-270927BCF711}"/>
+              </a:ext>
+            </a:extLst>
+          </p:cNvPr>
+          <p:cNvSpPr>
+            <a:spLocks noChangeArrowheads="1"/>
+          </p:cNvSpPr>
+          <p:nvPr/>
+        </p:nvSpPr>
+        <p:spPr bwMode="auto">
+          <a:xfrm>
+            <a:off x="6580429" y="1582355"/>
+            <a:ext cx="5307167" cy="3493264"/>
+          </a:xfrm>
+          <a:prstGeom prst="rect">
+            <a:avLst/>
+          </a:prstGeom>
+          <a:noFill/>
+          <a:ln>
+            <a:noFill/>
+          </a:ln>
+          <a:effectLst/>
+          <a:extLst>
+            <a:ext uri="{909E8E84-426E-40DD-AFC4-6F175D3DCCD1}">
+              <a14:hiddenFill xmlns:a14="http://schemas.microsoft.com/office/drawing/2010/main">
+                <a:solidFill>
+                  <a:schemeClr val="accent1"/>
+                </a:solidFill>
+              </a14:hiddenFill>
+            </a:ext>
+            <a:ext uri="{91240B29-F687-4F45-9708-019B960494DF}">
+              <a14:hiddenLine xmlns:a14="http://schemas.microsoft.com/office/drawing/2010/main" w="9525">
+                <a:solidFill>
+                  <a:schemeClr val="tx1"/>
+                </a:solidFill>
+                <a:miter lim="800000"/>
+                <a:headEnd/>
+                <a:tailEnd/>
+              </a14:hiddenLine>
+            </a:ext>
+            <a:ext uri="{AF507438-7753-43E0-B8FC-AC1667EBCBE1}">
+              <a14:hiddenEffects xmlns:a14="http://schemas.microsoft.com/office/drawing/2010/main">
+                <a:effectLst>
+                  <a:outerShdw dist="35921" dir="2700000" algn="ctr" rotWithShape="0">
+                    <a:schemeClr val="bg2"/>
+                  </a:outerShdw>
+                </a:effectLst>
+              </a14:hiddenEffects>
+            </a:ext>
+          </a:extLst>
+        </p:spPr>
+        <p:txBody>
+          <a:bodyPr vert="horz" wrap="square" lIns="91440" tIns="0" rIns="91440" bIns="45720" numCol="1" anchor="ctr" anchorCtr="0" compatLnSpc="1">
+            <a:prstTxWarp prst="textNoShape">
+              <a:avLst/>
+            </a:prstTxWarp>
+            <a:spAutoFit/>
+          </a:bodyPr>
+          <a:lstStyle/>
+          <a:p>
+            <a:pPr marL="0" marR="0" lvl="0" indent="0" algn="just" defTabSz="914400" rtl="0" eaLnBrk="0" fontAlgn="base" latinLnBrk="0" hangingPunct="0">
+              <a:lnSpc>
+                <a:spcPct val="100000"/>
+              </a:lnSpc>
+              <a:spcBef>
+                <a:spcPct val="0"/>
+              </a:spcBef>
+              <a:spcAft>
+                <a:spcPct val="0"/>
+              </a:spcAft>
+              <a:buClrTx/>
+              <a:buSzTx/>
+              <a:buFontTx/>
+              <a:buNone/>
+              <a:tabLst/>
+            </a:pPr>
+            <a:r>
+              <a:rPr kumimoji="0" lang="es-ES" altLang="es-ES" sz="1600" b="0" i="0" u="none" strike="noStrike" cap="none" normalizeH="0" baseline="0" dirty="0">
+                <a:ln>
+                  <a:noFill/>
+                </a:ln>
+                <a:solidFill>
+                  <a:schemeClr val="tx1"/>
+                </a:solidFill>
+                <a:effectLst/>
+                <a:latin typeface="Google Sans Text"/>
+              </a:rPr>
+              <a:t>Para diseñar el MZI como un filtro con transmisión máxima a 1550 nm , </a:t>
+            </a:r>
+            <a:r>
+              <a:rPr lang="es-ES" altLang="es-ES" sz="1600" dirty="0">
+                <a:latin typeface="Google Sans Text"/>
+              </a:rPr>
+              <a:t>primero se ha establecido una configuración simétrica de los materiales de los dos. Así solo se establece una asimetría en su longitud.</a:t>
+            </a:r>
+            <a:r>
+              <a:rPr kumimoji="0" lang="es-ES" altLang="es-ES" sz="1600" b="0" i="0" u="none" strike="noStrike" cap="none" normalizeH="0" baseline="0" dirty="0">
+                <a:ln>
+                  <a:noFill/>
+                </a:ln>
+                <a:solidFill>
+                  <a:schemeClr val="tx1"/>
+                </a:solidFill>
+                <a:effectLst/>
+                <a:latin typeface="Google Sans Text"/>
+              </a:rPr>
+              <a:t> Luego, se ha calculado su índice efectivo exacto a 1.55 </a:t>
+            </a:r>
+            <a:r>
+              <a:rPr kumimoji="0" lang="es-ES" altLang="es-ES" sz="1600" b="0" i="0" u="none" strike="noStrike" cap="none" normalizeH="0" baseline="0" dirty="0" err="1">
+                <a:ln>
+                  <a:noFill/>
+                </a:ln>
+                <a:solidFill>
+                  <a:schemeClr val="tx1"/>
+                </a:solidFill>
+                <a:effectLst/>
+                <a:latin typeface="Google Sans Text"/>
+              </a:rPr>
+              <a:t>um</a:t>
+            </a:r>
+            <a:r>
+              <a:rPr kumimoji="0" lang="es-ES" altLang="es-ES" sz="1600" b="0" i="0" u="none" strike="noStrike" cap="none" normalizeH="0" baseline="0" dirty="0">
+                <a:ln>
+                  <a:noFill/>
+                </a:ln>
+                <a:solidFill>
+                  <a:schemeClr val="tx1"/>
+                </a:solidFill>
+                <a:effectLst/>
+                <a:latin typeface="Google Sans Text"/>
+              </a:rPr>
+              <a:t> a partir de interpolación cúbica y se ha determinado el desbalance de longitud (</a:t>
+            </a:r>
+            <a:r>
+              <a:rPr kumimoji="0" lang="es-ES" altLang="es-ES" sz="1600" b="0" i="0" u="none" strike="noStrike" cap="none" normalizeH="0" baseline="0" dirty="0" err="1">
+                <a:ln>
+                  <a:noFill/>
+                </a:ln>
+                <a:solidFill>
+                  <a:schemeClr val="tx1"/>
+                </a:solidFill>
+                <a:effectLst/>
+                <a:latin typeface="Google Sans Text"/>
+              </a:rPr>
+              <a:t>delta_L</a:t>
+            </a:r>
+            <a:r>
+              <a:rPr kumimoji="0" lang="es-ES" altLang="es-ES" sz="1600" b="0" i="0" u="none" strike="noStrike" cap="none" normalizeH="0" baseline="0" dirty="0">
+                <a:ln>
+                  <a:noFill/>
+                </a:ln>
+                <a:solidFill>
+                  <a:schemeClr val="tx1"/>
+                </a:solidFill>
+                <a:effectLst/>
+                <a:latin typeface="Google Sans Text"/>
+              </a:rPr>
+              <a:t>) necesario para </a:t>
+            </a:r>
+            <a:r>
+              <a:rPr lang="es-ES" altLang="es-ES" sz="1600" dirty="0">
+                <a:latin typeface="Google Sans Text"/>
+              </a:rPr>
+              <a:t>cumplir con la </a:t>
+            </a:r>
+            <a:r>
+              <a:rPr kumimoji="0" lang="es-ES" altLang="es-ES" sz="1600" b="0" i="0" u="none" strike="noStrike" cap="none" normalizeH="0" baseline="0" dirty="0">
+                <a:ln>
+                  <a:noFill/>
+                </a:ln>
+                <a:solidFill>
+                  <a:schemeClr val="tx1"/>
+                </a:solidFill>
+                <a:effectLst/>
+                <a:latin typeface="Google Sans Text"/>
+              </a:rPr>
+              <a:t>condición de máxima transmisión (diferencia de fase múltiplo </a:t>
+            </a:r>
+            <a:r>
+              <a:rPr kumimoji="0" lang="es-ES" altLang="es-ES" sz="1600" b="0" i="0" u="none" strike="noStrike" cap="none" normalizeH="0" baseline="0" dirty="0" err="1">
+                <a:ln>
+                  <a:noFill/>
+                </a:ln>
+                <a:solidFill>
+                  <a:schemeClr val="tx1"/>
+                </a:solidFill>
+                <a:effectLst/>
+                <a:latin typeface="Google Sans Text"/>
+              </a:rPr>
+              <a:t>dentero</a:t>
+            </a:r>
+            <a:r>
+              <a:rPr kumimoji="0" lang="es-ES" altLang="es-ES" sz="1600" b="0" i="0" u="none" strike="noStrike" cap="none" normalizeH="0" baseline="0" dirty="0">
+                <a:ln>
+                  <a:noFill/>
+                </a:ln>
+                <a:solidFill>
+                  <a:schemeClr val="tx1"/>
+                </a:solidFill>
+                <a:effectLst/>
+                <a:latin typeface="Google Sans Text"/>
+              </a:rPr>
+              <a:t> de 2pi y con un orden de interferencia de m=20). </a:t>
+            </a:r>
+            <a:r>
+              <a:rPr lang="es-ES" altLang="es-ES" sz="1600" dirty="0">
+                <a:latin typeface="Google Sans Text"/>
+              </a:rPr>
+              <a:t>El espectro obtenido con SAX con esa </a:t>
+            </a:r>
+            <a:r>
+              <a:rPr lang="es-ES" altLang="es-ES" sz="1600" dirty="0" err="1">
+                <a:latin typeface="Google Sans Text"/>
+              </a:rPr>
+              <a:t>delta_L</a:t>
+            </a:r>
+            <a:r>
+              <a:rPr lang="es-ES" altLang="es-ES" sz="1600" dirty="0">
+                <a:latin typeface="Google Sans Text"/>
+              </a:rPr>
+              <a:t> </a:t>
+            </a:r>
+            <a:r>
+              <a:rPr kumimoji="0" lang="es-ES" altLang="es-ES" sz="1600" b="0" i="0" u="none" strike="noStrike" cap="none" normalizeH="0" baseline="0" dirty="0">
+                <a:ln>
+                  <a:noFill/>
+                </a:ln>
+                <a:solidFill>
+                  <a:schemeClr val="tx1"/>
+                </a:solidFill>
+                <a:effectLst/>
+                <a:latin typeface="Google Sans Text"/>
+              </a:rPr>
+              <a:t>confirma el comportamiento de filtro periódico. En la gráfica se observa que el puerto cruzado (Cross, H01) llega a una interferencia totalmente constructiva, con su pico de máxima transmisión de manera exacta sobre la línea objetivo de 1550 nm, cumpliendo así con los requisitos del diseño.</a:t>
+            </a:r>
+            <a:endParaRPr kumimoji="0" lang="es-ES" altLang="es-ES" sz="1600" b="0" i="0" u="none" strike="noStrike" cap="none" normalizeH="0" baseline="0" dirty="0">
+              <a:ln>
+                <a:noFill/>
+              </a:ln>
+              <a:solidFill>
+                <a:schemeClr val="tx1"/>
+              </a:solidFill>
+              <a:effectLst/>
+              <a:latin typeface="Arial" panose="020B0604020202020204" pitchFamily="34" charset="0"/>
+            </a:endParaRPr>
+          </a:p>
+        </p:txBody>
+      </p:sp>
+    </p:spTree>
+    <p:extLst>
+      <p:ext uri="{BB962C8B-B14F-4D97-AF65-F5344CB8AC3E}">
+        <p14:creationId xmlns:p14="http://schemas.microsoft.com/office/powerpoint/2010/main" val="409402419"/>
+      </p:ext>
+    </p:extLst>
+  </p:cSld>
+  <p:clrMapOvr>
+    <a:masterClrMapping/>
+  </p:clrMapOvr>
+</p:sld>
+</file>
+
+<file path=ppt/slides/slide11.xml><?xml version="1.0" encoding="utf-8"?>
+<p:sld xmlns:a="http://schemas.openxmlformats.org/drawingml/2006/main" xmlns:r="http://schemas.openxmlformats.org/officeDocument/2006/relationships" xmlns:p="http://schemas.openxmlformats.org/presentationml/2006/main">
+  <p:cSld>
+    <p:spTree>
+      <p:nvGrpSpPr>
+        <p:cNvPr id="1" name="">
+          <a:extLst>
+            <a:ext uri="{FF2B5EF4-FFF2-40B4-BE49-F238E27FC236}">
+              <a16:creationId xmlns:a16="http://schemas.microsoft.com/office/drawing/2014/main" id="{E4D35EA3-F6CC-AFBB-2C2F-D5FE1BD9DC8A}"/>
+            </a:ext>
+          </a:extLst>
+        </p:cNvPr>
+        <p:cNvGrpSpPr/>
+        <p:nvPr/>
+      </p:nvGrpSpPr>
+      <p:grpSpPr>
+        <a:xfrm>
+          <a:off x="0" y="0"/>
+          <a:ext cx="0" cy="0"/>
+          <a:chOff x="0" y="0"/>
+          <a:chExt cx="0" cy="0"/>
+        </a:xfrm>
+      </p:grpSpPr>
+      <p:sp>
+        <p:nvSpPr>
+          <p:cNvPr id="2" name="Título 1">
+            <a:extLst>
+              <a:ext uri="{FF2B5EF4-FFF2-40B4-BE49-F238E27FC236}">
+                <a16:creationId xmlns:a16="http://schemas.microsoft.com/office/drawing/2014/main" id="{A04479EF-EB01-A4AA-BC6D-FB9EDB0F9C0D}"/>
+              </a:ext>
+            </a:extLst>
+          </p:cNvPr>
+          <p:cNvSpPr>
+            <a:spLocks noGrp="1"/>
+          </p:cNvSpPr>
+          <p:nvPr>
+            <p:ph type="title"/>
+          </p:nvPr>
+        </p:nvSpPr>
+        <p:spPr>
+          <a:xfrm>
+            <a:off x="600075" y="316301"/>
+            <a:ext cx="10991850" cy="307777"/>
+          </a:xfrm>
+        </p:spPr>
+        <p:txBody>
+          <a:bodyPr/>
+          <a:lstStyle/>
+          <a:p>
+            <a:r>
+              <a:rPr lang="es-ES" dirty="0"/>
+              <a:t>RESULTADO ASSESSMENT 5</a:t>
+            </a:r>
+          </a:p>
+        </p:txBody>
+      </p:sp>
+      <p:sp>
+        <p:nvSpPr>
+          <p:cNvPr id="4" name="Marcador de pie de página 3">
+            <a:extLst>
+              <a:ext uri="{FF2B5EF4-FFF2-40B4-BE49-F238E27FC236}">
+                <a16:creationId xmlns:a16="http://schemas.microsoft.com/office/drawing/2014/main" id="{F963BC45-0BFE-2131-A2DC-B57F6122FAA6}"/>
+              </a:ext>
+            </a:extLst>
+          </p:cNvPr>
+          <p:cNvSpPr>
+            <a:spLocks noGrp="1"/>
+          </p:cNvSpPr>
+          <p:nvPr>
+            <p:ph type="ftr" sz="quarter" idx="5"/>
+          </p:nvPr>
+        </p:nvSpPr>
+        <p:spPr/>
+        <p:txBody>
+          <a:bodyPr/>
+          <a:lstStyle/>
+          <a:p>
+            <a:pPr marL="12700">
+              <a:spcBef>
+                <a:spcPts val="15"/>
+              </a:spcBef>
+            </a:pPr>
+            <a:r>
+              <a:rPr lang="es-ES" spc="-5"/>
+              <a:t>LAB 3. INTERFEROMETERS I</a:t>
+            </a:r>
+            <a:endParaRPr lang="es-ES" spc="-5" dirty="0"/>
+          </a:p>
+        </p:txBody>
+      </p:sp>
+      <p:sp>
+        <p:nvSpPr>
+          <p:cNvPr id="5" name="Marcador de número de diapositiva 4">
+            <a:extLst>
+              <a:ext uri="{FF2B5EF4-FFF2-40B4-BE49-F238E27FC236}">
+                <a16:creationId xmlns:a16="http://schemas.microsoft.com/office/drawing/2014/main" id="{AB4B94F4-35EE-40CB-81CF-89FACF367B9C}"/>
+              </a:ext>
+            </a:extLst>
+          </p:cNvPr>
+          <p:cNvSpPr>
+            <a:spLocks noGrp="1"/>
+          </p:cNvSpPr>
+          <p:nvPr>
+            <p:ph type="sldNum" sz="quarter" idx="7"/>
+          </p:nvPr>
+        </p:nvSpPr>
+        <p:spPr/>
+        <p:txBody>
+          <a:bodyPr/>
+          <a:lstStyle/>
+          <a:p>
+            <a:fld id="{B6F15528-21DE-4FAA-801E-634DDDAF4B2B}" type="slidenum">
+              <a:rPr lang="es-ES" smtClean="0"/>
+              <a:t>11</a:t>
+            </a:fld>
+            <a:endParaRPr lang="es-ES"/>
+          </a:p>
+        </p:txBody>
+      </p:sp>
+      <p:pic>
+        <p:nvPicPr>
+          <p:cNvPr id="6" name="Imagen 5">
+            <a:extLst>
+              <a:ext uri="{FF2B5EF4-FFF2-40B4-BE49-F238E27FC236}">
+                <a16:creationId xmlns:a16="http://schemas.microsoft.com/office/drawing/2014/main" id="{237D95F3-68DF-9109-5CC1-FD36629E5DCA}"/>
+              </a:ext>
+            </a:extLst>
+          </p:cNvPr>
+          <p:cNvPicPr>
+            <a:picLocks noChangeAspect="1"/>
+          </p:cNvPicPr>
+          <p:nvPr/>
+        </p:nvPicPr>
+        <p:blipFill>
+          <a:blip r:embed="rId2"/>
+          <a:stretch>
+            <a:fillRect/>
+          </a:stretch>
+        </p:blipFill>
+        <p:spPr>
+          <a:xfrm>
+            <a:off x="572084" y="838200"/>
+            <a:ext cx="5327073" cy="3276600"/>
+          </a:xfrm>
+          <a:prstGeom prst="rect">
+            <a:avLst/>
+          </a:prstGeom>
+        </p:spPr>
+      </p:pic>
+      <p:sp>
+        <p:nvSpPr>
+          <p:cNvPr id="7" name="Rectangle 1">
+            <a:extLst>
+              <a:ext uri="{FF2B5EF4-FFF2-40B4-BE49-F238E27FC236}">
+                <a16:creationId xmlns:a16="http://schemas.microsoft.com/office/drawing/2014/main" id="{BBB22FF9-B8EB-796D-4302-850CFBD813AF}"/>
+              </a:ext>
+            </a:extLst>
+          </p:cNvPr>
+          <p:cNvSpPr>
+            <a:spLocks noChangeArrowheads="1"/>
+          </p:cNvSpPr>
+          <p:nvPr/>
+        </p:nvSpPr>
+        <p:spPr bwMode="auto">
+          <a:xfrm>
+            <a:off x="6248400" y="1345420"/>
+            <a:ext cx="5181600" cy="2262158"/>
+          </a:xfrm>
+          <a:prstGeom prst="rect">
+            <a:avLst/>
+          </a:prstGeom>
+          <a:noFill/>
+          <a:ln>
+            <a:noFill/>
+          </a:ln>
+          <a:effectLst/>
+          <a:extLst>
+            <a:ext uri="{909E8E84-426E-40DD-AFC4-6F175D3DCCD1}">
+              <a14:hiddenFill xmlns:a14="http://schemas.microsoft.com/office/drawing/2010/main">
+                <a:solidFill>
+                  <a:schemeClr val="accent1"/>
+                </a:solidFill>
+              </a14:hiddenFill>
+            </a:ext>
+            <a:ext uri="{91240B29-F687-4F45-9708-019B960494DF}">
+              <a14:hiddenLine xmlns:a14="http://schemas.microsoft.com/office/drawing/2010/main" w="9525">
+                <a:solidFill>
+                  <a:schemeClr val="tx1"/>
+                </a:solidFill>
+                <a:miter lim="800000"/>
+                <a:headEnd/>
+                <a:tailEnd/>
+              </a14:hiddenLine>
+            </a:ext>
+            <a:ext uri="{AF507438-7753-43E0-B8FC-AC1667EBCBE1}">
+              <a14:hiddenEffects xmlns:a14="http://schemas.microsoft.com/office/drawing/2010/main">
+                <a:effectLst>
+                  <a:outerShdw dist="35921" dir="2700000" algn="ctr" rotWithShape="0">
+                    <a:schemeClr val="bg2"/>
+                  </a:outerShdw>
+                </a:effectLst>
+              </a14:hiddenEffects>
+            </a:ext>
+          </a:extLst>
+        </p:spPr>
+        <p:txBody>
+          <a:bodyPr vert="horz" wrap="square" lIns="91440" tIns="0" rIns="91440" bIns="45720" numCol="1" anchor="ctr" anchorCtr="0" compatLnSpc="1">
+            <a:prstTxWarp prst="textNoShape">
+              <a:avLst/>
+            </a:prstTxWarp>
+            <a:spAutoFit/>
+          </a:bodyPr>
+          <a:lstStyle/>
+          <a:p>
+            <a:pPr marL="0" marR="0" lvl="0" indent="0" algn="just" defTabSz="914400" rtl="0" eaLnBrk="0" fontAlgn="base" latinLnBrk="0" hangingPunct="0">
+              <a:lnSpc>
+                <a:spcPct val="100000"/>
+              </a:lnSpc>
+              <a:spcBef>
+                <a:spcPct val="0"/>
+              </a:spcBef>
+              <a:spcAft>
+                <a:spcPct val="0"/>
+              </a:spcAft>
+              <a:buClrTx/>
+              <a:buSzTx/>
+              <a:buFontTx/>
+              <a:buNone/>
+              <a:tabLst/>
+            </a:pPr>
+            <a:r>
+              <a:rPr lang="es-ES" altLang="es-ES" sz="1600" dirty="0">
+                <a:latin typeface="Google Sans Text"/>
+              </a:rPr>
+              <a:t>Ahora el puerto superior mantiene el mismo </a:t>
+            </a:r>
+            <a:r>
+              <a:rPr lang="es-ES" altLang="es-ES" sz="1600" dirty="0" err="1">
+                <a:latin typeface="Google Sans Text"/>
+              </a:rPr>
+              <a:t>cladding</a:t>
+            </a:r>
+            <a:r>
+              <a:rPr lang="es-ES" altLang="es-ES" sz="1600" dirty="0">
+                <a:latin typeface="Google Sans Text"/>
+              </a:rPr>
+              <a:t> pero el inferior ahora está en medio acuoso. Al cambiar el entorno de la guía de onda, el índice de refracción efectivo varía, lo que altera la velocidad de propagación de la luz y modifica el camino óptico recorrido en ese tramo. Ten la gráfica se puede ver que esta alteración genera una diferencia de fase adicional que genera un desplazamiento horizontal del patrón de respecto al espectro original, manteniendo prácticamente intactos la amplitud y el FSR.</a:t>
+            </a:r>
+          </a:p>
+        </p:txBody>
+      </p:sp>
+      <p:sp>
+        <p:nvSpPr>
+          <p:cNvPr id="8" name="CuadroTexto 7">
+            <a:extLst>
+              <a:ext uri="{FF2B5EF4-FFF2-40B4-BE49-F238E27FC236}">
+                <a16:creationId xmlns:a16="http://schemas.microsoft.com/office/drawing/2014/main" id="{F63BF62F-9E07-CE3F-2F9D-AF2FC0089617}"/>
+              </a:ext>
+            </a:extLst>
+          </p:cNvPr>
+          <p:cNvSpPr txBox="1"/>
+          <p:nvPr/>
+        </p:nvSpPr>
+        <p:spPr>
+          <a:xfrm>
+            <a:off x="685800" y="4366242"/>
+            <a:ext cx="10906125" cy="1323439"/>
+          </a:xfrm>
+          <a:prstGeom prst="rect">
+            <a:avLst/>
+          </a:prstGeom>
+          <a:noFill/>
+        </p:spPr>
+        <p:txBody>
+          <a:bodyPr wrap="square">
+            <a:spAutoFit/>
+          </a:bodyPr>
+          <a:lstStyle/>
+          <a:p>
+            <a:pPr algn="just"/>
+            <a:r>
+              <a:rPr lang="es-ES" sz="1600" dirty="0"/>
+              <a:t>Este tipo de diseño se podría usar para </a:t>
+            </a:r>
+            <a:r>
+              <a:rPr lang="es-ES" sz="1600" dirty="0" err="1"/>
+              <a:t>biosensado</a:t>
+            </a:r>
+            <a:r>
+              <a:rPr lang="es-ES" sz="1600" dirty="0"/>
+              <a:t>. Por un lado, esta el brazo de referencia y por el otro está el otro brazo que se deja expuesto al medio que se desee analizar. Dependiendo del fluido que lo recubra, cambiará el índice efectivo y por lo tanto un desplazamiento en el espectro. A partir de la medida de este desplazamiento, se podría deducir la concentración de la sustancia detectada.</a:t>
+            </a:r>
+          </a:p>
+          <a:p>
+            <a:pPr algn="just"/>
+            <a:endParaRPr lang="es-ES" sz="1600" dirty="0"/>
+          </a:p>
+        </p:txBody>
+      </p:sp>
+    </p:spTree>
+    <p:extLst>
+      <p:ext uri="{BB962C8B-B14F-4D97-AF65-F5344CB8AC3E}">
+        <p14:creationId xmlns:p14="http://schemas.microsoft.com/office/powerpoint/2010/main" val="3704534873"/>
+      </p:ext>
+    </p:extLst>
+  </p:cSld>
+  <p:clrMapOvr>
+    <a:masterClrMapping/>
+  </p:clrMapOvr>
+</p:sld>
+</file>
+
+<file path=ppt/slides/slide12.xml><?xml version="1.0" encoding="utf-8"?>
+<p:sld xmlns:a="http://schemas.openxmlformats.org/drawingml/2006/main" xmlns:r="http://schemas.openxmlformats.org/officeDocument/2006/relationships" xmlns:p="http://schemas.openxmlformats.org/presentationml/2006/main">
+  <p:cSld>
+    <p:spTree>
+      <p:nvGrpSpPr>
+        <p:cNvPr id="1" name="">
+          <a:extLst>
+            <a:ext uri="{FF2B5EF4-FFF2-40B4-BE49-F238E27FC236}">
+              <a16:creationId xmlns:a16="http://schemas.microsoft.com/office/drawing/2014/main" id="{B427BE13-3888-A747-ECCF-71DFC22514BA}"/>
+            </a:ext>
+          </a:extLst>
+        </p:cNvPr>
+        <p:cNvGrpSpPr/>
+        <p:nvPr/>
+      </p:nvGrpSpPr>
+      <p:grpSpPr>
+        <a:xfrm>
+          <a:off x="0" y="0"/>
+          <a:ext cx="0" cy="0"/>
+          <a:chOff x="0" y="0"/>
+          <a:chExt cx="0" cy="0"/>
+        </a:xfrm>
+      </p:grpSpPr>
+      <p:sp>
+        <p:nvSpPr>
+          <p:cNvPr id="2" name="Título 1">
+            <a:extLst>
+              <a:ext uri="{FF2B5EF4-FFF2-40B4-BE49-F238E27FC236}">
+                <a16:creationId xmlns:a16="http://schemas.microsoft.com/office/drawing/2014/main" id="{1C50859F-5E45-EAA1-170C-8ACCBF56DFF3}"/>
+              </a:ext>
+            </a:extLst>
+          </p:cNvPr>
+          <p:cNvSpPr>
+            <a:spLocks noGrp="1"/>
+          </p:cNvSpPr>
+          <p:nvPr>
+            <p:ph type="title"/>
+          </p:nvPr>
+        </p:nvSpPr>
+        <p:spPr>
+          <a:xfrm>
+            <a:off x="600075" y="316301"/>
+            <a:ext cx="10991850" cy="307777"/>
+          </a:xfrm>
+        </p:spPr>
+        <p:txBody>
+          <a:bodyPr/>
+          <a:lstStyle/>
+          <a:p>
+            <a:r>
+              <a:rPr lang="es-ES" dirty="0"/>
+              <a:t>RESULTADO ADVANCED LEVEL ASSESSMENT </a:t>
+            </a:r>
+          </a:p>
+        </p:txBody>
+      </p:sp>
+      <p:sp>
+        <p:nvSpPr>
+          <p:cNvPr id="4" name="Marcador de pie de página 3">
+            <a:extLst>
+              <a:ext uri="{FF2B5EF4-FFF2-40B4-BE49-F238E27FC236}">
+                <a16:creationId xmlns:a16="http://schemas.microsoft.com/office/drawing/2014/main" id="{8B4ECF35-CE5C-0926-D19B-A7DEEF586E70}"/>
+              </a:ext>
+            </a:extLst>
+          </p:cNvPr>
+          <p:cNvSpPr>
+            <a:spLocks noGrp="1"/>
+          </p:cNvSpPr>
+          <p:nvPr>
+            <p:ph type="ftr" sz="quarter" idx="5"/>
+          </p:nvPr>
+        </p:nvSpPr>
+        <p:spPr/>
+        <p:txBody>
+          <a:bodyPr/>
+          <a:lstStyle/>
+          <a:p>
+            <a:pPr marL="12700">
+              <a:spcBef>
+                <a:spcPts val="15"/>
+              </a:spcBef>
+            </a:pPr>
+            <a:r>
+              <a:rPr lang="es-ES" spc="-5"/>
+              <a:t>LAB 3. INTERFEROMETERS I</a:t>
+            </a:r>
+            <a:endParaRPr lang="es-ES" spc="-5" dirty="0"/>
+          </a:p>
+        </p:txBody>
+      </p:sp>
+      <p:sp>
+        <p:nvSpPr>
+          <p:cNvPr id="5" name="Marcador de número de diapositiva 4">
+            <a:extLst>
+              <a:ext uri="{FF2B5EF4-FFF2-40B4-BE49-F238E27FC236}">
+                <a16:creationId xmlns:a16="http://schemas.microsoft.com/office/drawing/2014/main" id="{CE84149E-8E98-0C13-E67C-0B7B08661B49}"/>
+              </a:ext>
+            </a:extLst>
+          </p:cNvPr>
+          <p:cNvSpPr>
+            <a:spLocks noGrp="1"/>
+          </p:cNvSpPr>
+          <p:nvPr>
+            <p:ph type="sldNum" sz="quarter" idx="7"/>
+          </p:nvPr>
+        </p:nvSpPr>
+        <p:spPr/>
+        <p:txBody>
+          <a:bodyPr/>
+          <a:lstStyle/>
+          <a:p>
+            <a:fld id="{B6F15528-21DE-4FAA-801E-634DDDAF4B2B}" type="slidenum">
+              <a:rPr lang="es-ES" smtClean="0"/>
+              <a:t>12</a:t>
+            </a:fld>
+            <a:endParaRPr lang="es-ES"/>
+          </a:p>
+        </p:txBody>
+      </p:sp>
+      <p:pic>
+        <p:nvPicPr>
+          <p:cNvPr id="6" name="Imagen 5">
+            <a:extLst>
+              <a:ext uri="{FF2B5EF4-FFF2-40B4-BE49-F238E27FC236}">
+                <a16:creationId xmlns:a16="http://schemas.microsoft.com/office/drawing/2014/main" id="{2A551314-E0D9-46A0-BBBA-CF30ADFEE090}"/>
+              </a:ext>
+            </a:extLst>
+          </p:cNvPr>
+          <p:cNvPicPr>
+            <a:picLocks noChangeAspect="1"/>
+          </p:cNvPicPr>
+          <p:nvPr/>
+        </p:nvPicPr>
+        <p:blipFill>
+          <a:blip r:embed="rId2"/>
+          <a:stretch>
+            <a:fillRect/>
+          </a:stretch>
+        </p:blipFill>
+        <p:spPr>
+          <a:xfrm>
+            <a:off x="152400" y="1331046"/>
+            <a:ext cx="5607168" cy="3595687"/>
+          </a:xfrm>
+          <a:prstGeom prst="rect">
+            <a:avLst/>
+          </a:prstGeom>
+        </p:spPr>
+      </p:pic>
+      <p:sp>
+        <p:nvSpPr>
+          <p:cNvPr id="8" name="CuadroTexto 7">
+            <a:extLst>
+              <a:ext uri="{FF2B5EF4-FFF2-40B4-BE49-F238E27FC236}">
+                <a16:creationId xmlns:a16="http://schemas.microsoft.com/office/drawing/2014/main" id="{18ED49D3-29B8-83D5-9393-87321B6E87DC}"/>
+              </a:ext>
+            </a:extLst>
+          </p:cNvPr>
+          <p:cNvSpPr txBox="1"/>
+          <p:nvPr/>
+        </p:nvSpPr>
+        <p:spPr>
+          <a:xfrm>
+            <a:off x="6096000" y="1236064"/>
+            <a:ext cx="5705668" cy="3785652"/>
+          </a:xfrm>
+          <a:prstGeom prst="rect">
+            <a:avLst/>
+          </a:prstGeom>
+          <a:noFill/>
+        </p:spPr>
+        <p:txBody>
+          <a:bodyPr wrap="square">
+            <a:spAutoFit/>
+          </a:bodyPr>
+          <a:lstStyle/>
+          <a:p>
+            <a:pPr algn="just"/>
+            <a:r>
+              <a:rPr lang="es-ES" sz="1600" dirty="0"/>
+              <a:t>Tenemos un sistema con dos MZI en serie configurados con desbalances de longitud distintos, esto genera periodicidades diferentes (FSR de 40 nm y 50 nm). En la gráfica, los dos MZI han sido sintonizados para que uno de sus picos de máxima transmisión coincida exactamente en 1550 nm. Al multiplicar sus respuestas individuales para obtener la función de transferencia global del sistema en cascada, se produce el efecto Vernier. </a:t>
+            </a:r>
+          </a:p>
+          <a:p>
+            <a:pPr algn="just"/>
+            <a:endParaRPr lang="es-ES" sz="1600" dirty="0"/>
+          </a:p>
+          <a:p>
+            <a:pPr algn="just"/>
+            <a:r>
+              <a:rPr lang="es-ES" sz="1600" dirty="0"/>
+              <a:t>En las longitudes de onda adyacentes a 1550nm, la diferencia de FSR provoca que los picos se desalineen, haciendo que un MZI atenúe la luz que el otro intenta dejar pasar. Este fenómeno suprime los lóbulos laterales (como se aprecia en la fuerte atenuación de las crestas secundarias en 1.515 </a:t>
+            </a:r>
+            <a:r>
+              <a:rPr lang="es-ES" sz="1600" dirty="0" err="1"/>
+              <a:t>um</a:t>
+            </a:r>
+            <a:r>
+              <a:rPr lang="es-ES" sz="1600" dirty="0"/>
+              <a:t> y 1.585 </a:t>
+            </a:r>
+            <a:r>
+              <a:rPr lang="es-ES" sz="1600" dirty="0" err="1"/>
+              <a:t>um</a:t>
+            </a:r>
+            <a:r>
+              <a:rPr lang="es-ES" sz="1600" dirty="0"/>
+              <a:t>).</a:t>
+            </a:r>
+          </a:p>
+          <a:p>
+            <a:pPr algn="just"/>
+            <a:r>
+              <a:rPr lang="es-ES" sz="1600" dirty="0"/>
+              <a:t>Esto convierte al sistema en un filtro óptico que aísla la banda central y aumenta el FSR del dispositivo.</a:t>
+            </a:r>
+          </a:p>
+        </p:txBody>
+      </p:sp>
+    </p:spTree>
+    <p:extLst>
+      <p:ext uri="{BB962C8B-B14F-4D97-AF65-F5344CB8AC3E}">
+        <p14:creationId xmlns:p14="http://schemas.microsoft.com/office/powerpoint/2010/main" val="1823125862"/>
+      </p:ext>
+    </p:extLst>
+  </p:cSld>
+  <p:clrMapOvr>
+    <a:masterClrMapping/>
+  </p:clrMapOvr>
+</p:sld>
+</file>
+
+<file path=ppt/slides/slide13.xml><?xml version="1.0" encoding="utf-8"?>
+<p:sld xmlns:a="http://schemas.openxmlformats.org/drawingml/2006/main" xmlns:r="http://schemas.openxmlformats.org/officeDocument/2006/relationships" xmlns:p="http://schemas.openxmlformats.org/presentationml/2006/main">
+  <p:cSld>
+    <p:spTree>
+      <p:nvGrpSpPr>
         <p:cNvPr id="1" name=""/>
         <p:cNvGrpSpPr/>
         <p:nvPr/>
@@ -2857,7 +3820,7 @@
           <a:p>
             <a:fld id="{B6F15528-21DE-4FAA-801E-634DDDAF4B2B}" type="slidenum">
               <a:rPr lang="es-ES" smtClean="0"/>
-              <a:t>10</a:t>
+              <a:t>13</a:t>
             </a:fld>
             <a:endParaRPr lang="es-ES"/>
           </a:p>
@@ -5791,7 +6754,7 @@
             </a:r>
             <a:r>
               <a:rPr lang="es-ES" sz="1600" dirty="0"/>
-              <a:t> = 0) y al uso de acopladores perfectamente balanceados al 50%, la amplitud de las oscilaciones van de 0 a 1, definiendo así un FSR finito y fácilmente medible.</a:t>
+              <a:t> = 0) y al uso de acopladores perfectamente balanceados al 50%, la amplitud de las oscilaciones van de 0 a 1, definiendo así un FSR finito y fácil de medir.</a:t>
             </a:r>
           </a:p>
         </p:txBody>
@@ -7796,7 +8759,7 @@
               <a:rPr lang="es-ES" altLang="es-ES" sz="1600" dirty="0">
                 <a:latin typeface="Google Sans Text"/>
               </a:rPr>
-              <a:t>Se ha establecido una configuración completamente balanceada, usando el mismo material (SOI) y la misma longitud geométrica (Lu=25um y </a:t>
+              <a:t>He usado una configuración completamente balanceada, usando el mismo material (SOI) y la misma longitud geométrica (Lu=25um y </a:t>
             </a:r>
             <a:r>
               <a:rPr lang="es-ES" altLang="es-ES" sz="1600" dirty="0" err="1">

</xml_diff>